<commit_message>
docs: laporan individu, rapikan paragraf, perbarui slide dan README
</commit_message>
<xml_diff>
--- a/submission/Slide_Presentasi.pptx
+++ b/submission/Slide_Presentasi.pptx
@@ -1554,7 +1554,7 @@
                 <a:ea typeface="Calibri" pitchFamily="34" charset="-122"/>
                 <a:cs typeface="Calibri" pitchFamily="34" charset="-120"/>
               </a:rPr>
-              <a:t>[Isi nama kelompok dan anggota]</a:t>
+              <a:t>[Isi nama dan NPM]</a:t>
             </a:r>
             <a:endParaRPr lang="en-US" sz="1400" dirty="0"/>
           </a:p>
@@ -5414,7 +5414,7 @@
                 <a:ea typeface="Calibri" pitchFamily="34" charset="-122"/>
                 <a:cs typeface="Calibri" pitchFamily="34" charset="-120"/>
               </a:rPr>
-              <a:t>6. Kontribusi tim dan roadmap</a:t>
+              <a:t>6. Kontribusi dan roadmap</a:t>
             </a:r>
             <a:endParaRPr lang="en-US" sz="2400" dirty="0"/>
           </a:p>
@@ -5504,7 +5504,7 @@
                           <a:ea typeface="Calibri" pitchFamily="34" charset="-122"/>
                           <a:cs typeface="Calibri" pitchFamily="34" charset="-120"/>
                         </a:rPr>
-                        <a:t>Anggota</a:t>
+                        <a:t>Nama</a:t>
                       </a:r>
                       <a:endParaRPr lang="en-US" sz="1100" dirty="0">
                         <a:latin typeface="Calibri" charset="0"/>
@@ -5710,7 +5710,7 @@
                           <a:ea typeface="Calibri" pitchFamily="34" charset="-122"/>
                           <a:cs typeface="Calibri" pitchFamily="34" charset="-120"/>
                         </a:rPr>
-                        <a:t>[Isi anggota 1]</a:t>
+                        <a:t>[Isi nama]</a:t>
                       </a:r>
                       <a:endParaRPr lang="en-US" sz="1050" dirty="0">
                         <a:latin typeface="Calibri" charset="0"/>
@@ -5775,401 +5775,7 @@
                           <a:ea typeface="Calibri" pitchFamily="34" charset="-122"/>
                           <a:cs typeface="Calibri" pitchFamily="34" charset="-120"/>
                         </a:rPr>
-                        <a:t>[Isi]</a:t>
-                      </a:r>
-                      <a:endParaRPr lang="en-US" sz="1050" dirty="0">
-                        <a:latin typeface="Calibri" charset="0"/>
-                        <a:ea typeface="Calibri" charset="0"/>
-                        <a:cs typeface="Calibri" charset="0"/>
-                      </a:endParaRPr>
-                    </a:p>
-                  </a:txBody>
-                  <a:tcPr marL="91440" marR="91440" marT="45720" marB="45720">
-                    <a:lnL w="6350" cap="flat" cmpd="sng" algn="ctr">
-                      <a:solidFill>
-                        <a:srgbClr val="BBBBBB"/>
-                      </a:solidFill>
-                      <a:prstDash val="solid"/>
-                      <a:round/>
-                      <a:headEnd type="none" w="med" len="med"/>
-                      <a:tailEnd type="none" w="med" len="med"/>
-                    </a:lnL>
-                    <a:lnR w="6350" cap="flat" cmpd="sng" algn="ctr">
-                      <a:solidFill>
-                        <a:srgbClr val="BBBBBB"/>
-                      </a:solidFill>
-                      <a:prstDash val="solid"/>
-                      <a:round/>
-                      <a:headEnd type="none" w="med" len="med"/>
-                      <a:tailEnd type="none" w="med" len="med"/>
-                    </a:lnR>
-                    <a:lnT w="6350" cap="flat" cmpd="sng" algn="ctr">
-                      <a:solidFill>
-                        <a:srgbClr val="BBBBBB"/>
-                      </a:solidFill>
-                      <a:prstDash val="solid"/>
-                      <a:round/>
-                      <a:headEnd type="none" w="med" len="med"/>
-                      <a:tailEnd type="none" w="med" len="med"/>
-                    </a:lnT>
-                    <a:lnB w="6350" cap="flat" cmpd="sng" algn="ctr">
-                      <a:solidFill>
-                        <a:srgbClr val="BBBBBB"/>
-                      </a:solidFill>
-                      <a:prstDash val="solid"/>
-                      <a:round/>
-                      <a:headEnd type="none" w="med" len="med"/>
-                      <a:tailEnd type="none" w="med" len="med"/>
-                    </a:lnB>
-                  </a:tcPr>
-                </a:tc>
-                <a:tc>
-                  <a:txBody>
-                    <a:bodyPr/>
-                    <a:lstStyle/>
-                    <a:p>
-                      <a:pPr indent="0" marL="0">
-                        <a:buNone/>
-                      </a:pPr>
-                      <a:r>
-                        <a:rPr lang="en-US" sz="1050" dirty="0">
-                          <a:solidFill>
-                            <a:srgbClr val="1B1F23"/>
-                          </a:solidFill>
-                          <a:latin typeface="Calibri" pitchFamily="34" charset="0"/>
-                          <a:ea typeface="Calibri" pitchFamily="34" charset="-122"/>
-                          <a:cs typeface="Calibri" pitchFamily="34" charset="-120"/>
-                        </a:rPr>
-                        <a:t>[Isi dari git log]</a:t>
-                      </a:r>
-                      <a:endParaRPr lang="en-US" sz="1050" dirty="0">
-                        <a:latin typeface="Calibri" charset="0"/>
-                        <a:ea typeface="Calibri" charset="0"/>
-                        <a:cs typeface="Calibri" charset="0"/>
-                      </a:endParaRPr>
-                    </a:p>
-                  </a:txBody>
-                  <a:tcPr marL="91440" marR="91440" marT="45720" marB="45720">
-                    <a:lnL w="6350" cap="flat" cmpd="sng" algn="ctr">
-                      <a:solidFill>
-                        <a:srgbClr val="BBBBBB"/>
-                      </a:solidFill>
-                      <a:prstDash val="solid"/>
-                      <a:round/>
-                      <a:headEnd type="none" w="med" len="med"/>
-                      <a:tailEnd type="none" w="med" len="med"/>
-                    </a:lnL>
-                    <a:lnR w="6350" cap="flat" cmpd="sng" algn="ctr">
-                      <a:solidFill>
-                        <a:srgbClr val="BBBBBB"/>
-                      </a:solidFill>
-                      <a:prstDash val="solid"/>
-                      <a:round/>
-                      <a:headEnd type="none" w="med" len="med"/>
-                      <a:tailEnd type="none" w="med" len="med"/>
-                    </a:lnR>
-                    <a:lnT w="6350" cap="flat" cmpd="sng" algn="ctr">
-                      <a:solidFill>
-                        <a:srgbClr val="BBBBBB"/>
-                      </a:solidFill>
-                      <a:prstDash val="solid"/>
-                      <a:round/>
-                      <a:headEnd type="none" w="med" len="med"/>
-                      <a:tailEnd type="none" w="med" len="med"/>
-                    </a:lnT>
-                    <a:lnB w="6350" cap="flat" cmpd="sng" algn="ctr">
-                      <a:solidFill>
-                        <a:srgbClr val="BBBBBB"/>
-                      </a:solidFill>
-                      <a:prstDash val="solid"/>
-                      <a:round/>
-                      <a:headEnd type="none" w="med" len="med"/>
-                      <a:tailEnd type="none" w="med" len="med"/>
-                    </a:lnB>
-                  </a:tcPr>
-                </a:tc>
-              </a:tr>
-              <a:tr h="0">
-                <a:tc>
-                  <a:txBody>
-                    <a:bodyPr/>
-                    <a:lstStyle/>
-                    <a:p>
-                      <a:pPr indent="0" marL="0">
-                        <a:buNone/>
-                      </a:pPr>
-                      <a:r>
-                        <a:rPr lang="en-US" sz="1050" dirty="0">
-                          <a:solidFill>
-                            <a:srgbClr val="1B1F23"/>
-                          </a:solidFill>
-                          <a:latin typeface="Calibri" pitchFamily="34" charset="0"/>
-                          <a:ea typeface="Calibri" pitchFamily="34" charset="-122"/>
-                          <a:cs typeface="Calibri" pitchFamily="34" charset="-120"/>
-                        </a:rPr>
-                        <a:t>[Isi anggota 2]</a:t>
-                      </a:r>
-                      <a:endParaRPr lang="en-US" sz="1050" dirty="0">
-                        <a:latin typeface="Calibri" charset="0"/>
-                        <a:ea typeface="Calibri" charset="0"/>
-                        <a:cs typeface="Calibri" charset="0"/>
-                      </a:endParaRPr>
-                    </a:p>
-                  </a:txBody>
-                  <a:tcPr marL="91440" marR="91440" marT="45720" marB="45720">
-                    <a:lnL w="6350" cap="flat" cmpd="sng" algn="ctr">
-                      <a:solidFill>
-                        <a:srgbClr val="BBBBBB"/>
-                      </a:solidFill>
-                      <a:prstDash val="solid"/>
-                      <a:round/>
-                      <a:headEnd type="none" w="med" len="med"/>
-                      <a:tailEnd type="none" w="med" len="med"/>
-                    </a:lnL>
-                    <a:lnR w="6350" cap="flat" cmpd="sng" algn="ctr">
-                      <a:solidFill>
-                        <a:srgbClr val="BBBBBB"/>
-                      </a:solidFill>
-                      <a:prstDash val="solid"/>
-                      <a:round/>
-                      <a:headEnd type="none" w="med" len="med"/>
-                      <a:tailEnd type="none" w="med" len="med"/>
-                    </a:lnR>
-                    <a:lnT w="6350" cap="flat" cmpd="sng" algn="ctr">
-                      <a:solidFill>
-                        <a:srgbClr val="BBBBBB"/>
-                      </a:solidFill>
-                      <a:prstDash val="solid"/>
-                      <a:round/>
-                      <a:headEnd type="none" w="med" len="med"/>
-                      <a:tailEnd type="none" w="med" len="med"/>
-                    </a:lnT>
-                    <a:lnB w="6350" cap="flat" cmpd="sng" algn="ctr">
-                      <a:solidFill>
-                        <a:srgbClr val="BBBBBB"/>
-                      </a:solidFill>
-                      <a:prstDash val="solid"/>
-                      <a:round/>
-                      <a:headEnd type="none" w="med" len="med"/>
-                      <a:tailEnd type="none" w="med" len="med"/>
-                    </a:lnB>
-                  </a:tcPr>
-                </a:tc>
-                <a:tc>
-                  <a:txBody>
-                    <a:bodyPr/>
-                    <a:lstStyle/>
-                    <a:p>
-                      <a:pPr indent="0" marL="0">
-                        <a:buNone/>
-                      </a:pPr>
-                      <a:r>
-                        <a:rPr lang="en-US" sz="1050" dirty="0">
-                          <a:solidFill>
-                            <a:srgbClr val="1B1F23"/>
-                          </a:solidFill>
-                          <a:latin typeface="Calibri" pitchFamily="34" charset="0"/>
-                          <a:ea typeface="Calibri" pitchFamily="34" charset="-122"/>
-                          <a:cs typeface="Calibri" pitchFamily="34" charset="-120"/>
-                        </a:rPr>
-                        <a:t>[Isi]</a:t>
-                      </a:r>
-                      <a:endParaRPr lang="en-US" sz="1050" dirty="0">
-                        <a:latin typeface="Calibri" charset="0"/>
-                        <a:ea typeface="Calibri" charset="0"/>
-                        <a:cs typeface="Calibri" charset="0"/>
-                      </a:endParaRPr>
-                    </a:p>
-                  </a:txBody>
-                  <a:tcPr marL="91440" marR="91440" marT="45720" marB="45720">
-                    <a:lnL w="6350" cap="flat" cmpd="sng" algn="ctr">
-                      <a:solidFill>
-                        <a:srgbClr val="BBBBBB"/>
-                      </a:solidFill>
-                      <a:prstDash val="solid"/>
-                      <a:round/>
-                      <a:headEnd type="none" w="med" len="med"/>
-                      <a:tailEnd type="none" w="med" len="med"/>
-                    </a:lnL>
-                    <a:lnR w="6350" cap="flat" cmpd="sng" algn="ctr">
-                      <a:solidFill>
-                        <a:srgbClr val="BBBBBB"/>
-                      </a:solidFill>
-                      <a:prstDash val="solid"/>
-                      <a:round/>
-                      <a:headEnd type="none" w="med" len="med"/>
-                      <a:tailEnd type="none" w="med" len="med"/>
-                    </a:lnR>
-                    <a:lnT w="6350" cap="flat" cmpd="sng" algn="ctr">
-                      <a:solidFill>
-                        <a:srgbClr val="BBBBBB"/>
-                      </a:solidFill>
-                      <a:prstDash val="solid"/>
-                      <a:round/>
-                      <a:headEnd type="none" w="med" len="med"/>
-                      <a:tailEnd type="none" w="med" len="med"/>
-                    </a:lnT>
-                    <a:lnB w="6350" cap="flat" cmpd="sng" algn="ctr">
-                      <a:solidFill>
-                        <a:srgbClr val="BBBBBB"/>
-                      </a:solidFill>
-                      <a:prstDash val="solid"/>
-                      <a:round/>
-                      <a:headEnd type="none" w="med" len="med"/>
-                      <a:tailEnd type="none" w="med" len="med"/>
-                    </a:lnB>
-                  </a:tcPr>
-                </a:tc>
-                <a:tc>
-                  <a:txBody>
-                    <a:bodyPr/>
-                    <a:lstStyle/>
-                    <a:p>
-                      <a:pPr indent="0" marL="0">
-                        <a:buNone/>
-                      </a:pPr>
-                      <a:r>
-                        <a:rPr lang="en-US" sz="1050" dirty="0">
-                          <a:solidFill>
-                            <a:srgbClr val="1B1F23"/>
-                          </a:solidFill>
-                          <a:latin typeface="Calibri" pitchFamily="34" charset="0"/>
-                          <a:ea typeface="Calibri" pitchFamily="34" charset="-122"/>
-                          <a:cs typeface="Calibri" pitchFamily="34" charset="-120"/>
-                        </a:rPr>
-                        <a:t>[Isi dari git log]</a:t>
-                      </a:r>
-                      <a:endParaRPr lang="en-US" sz="1050" dirty="0">
-                        <a:latin typeface="Calibri" charset="0"/>
-                        <a:ea typeface="Calibri" charset="0"/>
-                        <a:cs typeface="Calibri" charset="0"/>
-                      </a:endParaRPr>
-                    </a:p>
-                  </a:txBody>
-                  <a:tcPr marL="91440" marR="91440" marT="45720" marB="45720">
-                    <a:lnL w="6350" cap="flat" cmpd="sng" algn="ctr">
-                      <a:solidFill>
-                        <a:srgbClr val="BBBBBB"/>
-                      </a:solidFill>
-                      <a:prstDash val="solid"/>
-                      <a:round/>
-                      <a:headEnd type="none" w="med" len="med"/>
-                      <a:tailEnd type="none" w="med" len="med"/>
-                    </a:lnL>
-                    <a:lnR w="6350" cap="flat" cmpd="sng" algn="ctr">
-                      <a:solidFill>
-                        <a:srgbClr val="BBBBBB"/>
-                      </a:solidFill>
-                      <a:prstDash val="solid"/>
-                      <a:round/>
-                      <a:headEnd type="none" w="med" len="med"/>
-                      <a:tailEnd type="none" w="med" len="med"/>
-                    </a:lnR>
-                    <a:lnT w="6350" cap="flat" cmpd="sng" algn="ctr">
-                      <a:solidFill>
-                        <a:srgbClr val="BBBBBB"/>
-                      </a:solidFill>
-                      <a:prstDash val="solid"/>
-                      <a:round/>
-                      <a:headEnd type="none" w="med" len="med"/>
-                      <a:tailEnd type="none" w="med" len="med"/>
-                    </a:lnT>
-                    <a:lnB w="6350" cap="flat" cmpd="sng" algn="ctr">
-                      <a:solidFill>
-                        <a:srgbClr val="BBBBBB"/>
-                      </a:solidFill>
-                      <a:prstDash val="solid"/>
-                      <a:round/>
-                      <a:headEnd type="none" w="med" len="med"/>
-                      <a:tailEnd type="none" w="med" len="med"/>
-                    </a:lnB>
-                  </a:tcPr>
-                </a:tc>
-              </a:tr>
-              <a:tr h="0">
-                <a:tc>
-                  <a:txBody>
-                    <a:bodyPr/>
-                    <a:lstStyle/>
-                    <a:p>
-                      <a:pPr indent="0" marL="0">
-                        <a:buNone/>
-                      </a:pPr>
-                      <a:r>
-                        <a:rPr lang="en-US" sz="1050" dirty="0">
-                          <a:solidFill>
-                            <a:srgbClr val="1B1F23"/>
-                          </a:solidFill>
-                          <a:latin typeface="Calibri" pitchFamily="34" charset="0"/>
-                          <a:ea typeface="Calibri" pitchFamily="34" charset="-122"/>
-                          <a:cs typeface="Calibri" pitchFamily="34" charset="-120"/>
-                        </a:rPr>
-                        <a:t>[Isi anggota 3]</a:t>
-                      </a:r>
-                      <a:endParaRPr lang="en-US" sz="1050" dirty="0">
-                        <a:latin typeface="Calibri" charset="0"/>
-                        <a:ea typeface="Calibri" charset="0"/>
-                        <a:cs typeface="Calibri" charset="0"/>
-                      </a:endParaRPr>
-                    </a:p>
-                  </a:txBody>
-                  <a:tcPr marL="91440" marR="91440" marT="45720" marB="45720">
-                    <a:lnL w="6350" cap="flat" cmpd="sng" algn="ctr">
-                      <a:solidFill>
-                        <a:srgbClr val="BBBBBB"/>
-                      </a:solidFill>
-                      <a:prstDash val="solid"/>
-                      <a:round/>
-                      <a:headEnd type="none" w="med" len="med"/>
-                      <a:tailEnd type="none" w="med" len="med"/>
-                    </a:lnL>
-                    <a:lnR w="6350" cap="flat" cmpd="sng" algn="ctr">
-                      <a:solidFill>
-                        <a:srgbClr val="BBBBBB"/>
-                      </a:solidFill>
-                      <a:prstDash val="solid"/>
-                      <a:round/>
-                      <a:headEnd type="none" w="med" len="med"/>
-                      <a:tailEnd type="none" w="med" len="med"/>
-                    </a:lnR>
-                    <a:lnT w="6350" cap="flat" cmpd="sng" algn="ctr">
-                      <a:solidFill>
-                        <a:srgbClr val="BBBBBB"/>
-                      </a:solidFill>
-                      <a:prstDash val="solid"/>
-                      <a:round/>
-                      <a:headEnd type="none" w="med" len="med"/>
-                      <a:tailEnd type="none" w="med" len="med"/>
-                    </a:lnT>
-                    <a:lnB w="6350" cap="flat" cmpd="sng" algn="ctr">
-                      <a:solidFill>
-                        <a:srgbClr val="BBBBBB"/>
-                      </a:solidFill>
-                      <a:prstDash val="solid"/>
-                      <a:round/>
-                      <a:headEnd type="none" w="med" len="med"/>
-                      <a:tailEnd type="none" w="med" len="med"/>
-                    </a:lnB>
-                  </a:tcPr>
-                </a:tc>
-                <a:tc>
-                  <a:txBody>
-                    <a:bodyPr/>
-                    <a:lstStyle/>
-                    <a:p>
-                      <a:pPr indent="0" marL="0">
-                        <a:buNone/>
-                      </a:pPr>
-                      <a:r>
-                        <a:rPr lang="en-US" sz="1050" dirty="0">
-                          <a:solidFill>
-                            <a:srgbClr val="1B1F23"/>
-                          </a:solidFill>
-                          <a:latin typeface="Calibri" pitchFamily="34" charset="0"/>
-                          <a:ea typeface="Calibri" pitchFamily="34" charset="-122"/>
-                          <a:cs typeface="Calibri" pitchFamily="34" charset="-120"/>
-                        </a:rPr>
-                        <a:t>[Isi]</a:t>
+                        <a:t>Dikerjakan individu: desain, kontrak, tes, audit, deployment, dokumentasi</a:t>
                       </a:r>
                       <a:endParaRPr lang="en-US" sz="1050" dirty="0">
                         <a:latin typeface="Calibri" charset="0"/>

</xml_diff>